<commit_message>
style: rediseño visual de presentaciones pptx con letras grandes y sintesis ejecutiva
</commit_message>
<xml_diff>
--- a/docs/PRESENTACION_APLICACION_WEB.pptx
+++ b/docs/PRESENTACION_APLICACION_WEB.pptx
@@ -3109,7 +3109,7 @@
             <a:avLst/>
           </a:prstGeom>
           <a:solidFill>
-            <a:srgbClr val="0B0F19"/>
+            <a:srgbClr val="0A0E17"/>
           </a:solidFill>
           <a:ln>
             <a:noFill/>
@@ -3145,18 +3145,18 @@
         </p:nvSpPr>
         <p:spPr>
           <a:xfrm>
-            <a:off x="1371600" y="1097280"/>
-            <a:ext cx="9448495" cy="4663440"/>
+            <a:off x="1097280" y="914400"/>
+            <a:ext cx="9997135" cy="5029200"/>
           </a:xfrm>
           <a:prstGeom prst="roundRect">
             <a:avLst/>
           </a:prstGeom>
           <a:solidFill>
-            <a:srgbClr val="181F2E"/>
+            <a:srgbClr val="161E2E"/>
           </a:solidFill>
-          <a:ln w="12700">
+          <a:ln w="19050">
             <a:solidFill>
-              <a:srgbClr val="1DB954"/>
+              <a:srgbClr val="10B981"/>
             </a:solidFill>
           </a:ln>
         </p:spPr>
@@ -3190,8 +3190,8 @@
         </p:nvSpPr>
         <p:spPr>
           <a:xfrm>
-            <a:off x="1828800" y="1463040"/>
-            <a:ext cx="8534095" cy="3931920"/>
+            <a:off x="1463040" y="1371600"/>
+            <a:ext cx="9265615" cy="4114800"/>
           </a:xfrm>
           <a:prstGeom prst="rect">
             <a:avLst/>
@@ -3206,61 +3206,69 @@
           <a:p>
             <a:pPr algn="ctr"/>
             <a:r>
-              <a:rPr sz="2800" b="1">
-                <a:solidFill>
-                  <a:srgbClr val="1DB954"/>
+              <a:rPr sz="3600" b="1">
+                <a:solidFill>
+                  <a:srgbClr val="10B981"/>
                 </a:solidFill>
               </a:rPr>
-              <a:t>PLATAFORMA WEB: SOUNDDATA ANALYTICS
+              <a:t>SOUNDDATA ANALYTICS
 </a:t>
             </a:r>
           </a:p>
           <a:p>
-            <a:pPr algn="ctr"/>
-            <a:r>
-              <a:rPr sz="1600" b="1">
-                <a:solidFill>
-                  <a:srgbClr val="F8FAFC"/>
+            <a:pPr algn="ctr">
+              <a:spcBef>
+                <a:spcPts val="800"/>
+              </a:spcBef>
+            </a:pPr>
+            <a:r>
+              <a:rPr sz="2000" b="1">
+                <a:solidFill>
+                  <a:srgbClr val="FFFFFF"/>
                 </a:solidFill>
               </a:rPr>
-              <a:t>Inteligencia de Datos y Simulación Predictiva para la Industria Musical
+              <a:t>Plataforma Web de Inteligencia y Simulación Musical
 </a:t>
             </a:r>
           </a:p>
           <a:p>
-            <a:pPr algn="ctr"/>
+            <a:pPr algn="ctr">
+              <a:spcBef>
+                <a:spcPts val="1600"/>
+              </a:spcBef>
+            </a:pPr>
+            <a:r>
+              <a:rPr sz="1500" b="1">
+                <a:solidFill>
+                  <a:srgbClr val="38BDF8"/>
+                </a:solidFill>
+              </a:rPr>
+              <a:t>FastAPI  •  Bootstrap 5 Dark  •  SQLite  •  Machine Learning
+</a:t>
+            </a:r>
+          </a:p>
+          <a:p>
+            <a:pPr algn="ctr">
+              <a:spcBef>
+                <a:spcPts val="2800"/>
+              </a:spcBef>
+            </a:pPr>
+            <a:r>
+              <a:rPr sz="1300" b="0">
+                <a:solidFill>
+                  <a:srgbClr val="CBD5E1"/>
+                </a:solidFill>
+              </a:rPr>
+              <a:t>Demostración Funcional y Vistas de Usuario
+</a:t>
+            </a:r>
             <a:r>
               <a:rPr sz="1200" b="0">
                 <a:solidFill>
                   <a:srgbClr val="94A3B8"/>
                 </a:solidFill>
               </a:rPr>
-              <a:t>Demostración de Funcionalidades, Vistas Interactivas y Persistencia Transaccional
-</a:t>
-            </a:r>
-          </a:p>
-          <a:p>
-            <a:pPr algn="ctr"/>
-            <a:r>
-              <a:rPr sz="1100" b="0">
-                <a:solidFill>
-                  <a:srgbClr val="F8FAFC"/>
-                </a:solidFill>
-              </a:rPr>
-              <a:t>Equipo: Vicente Muñoz • Juan Ortiz • Jordan Murillo • Jorge Moncada • Jose Mendez • Bastian Parraguez
-</a:t>
-            </a:r>
-          </a:p>
-          <a:p>
-            <a:pPr algn="ctr"/>
-            <a:r>
-              <a:rPr sz="1000" b="0">
-                <a:solidFill>
-                  <a:srgbClr val="38BDF8"/>
-                </a:solidFill>
-              </a:rPr>
-              <a:t>FastAPI • Bootstrap 5 Dark • Chart.js • SQLite • Scikit-Learn
-Universidad Santo Tomás — Minería de Datos (IEI-067)</a:t>
+              <a:t>Universidad Santo Tomás — Minería de Datos (IEI-067)</a:t>
             </a:r>
           </a:p>
         </p:txBody>
@@ -3298,7 +3306,7 @@
             <a:avLst/>
           </a:prstGeom>
           <a:solidFill>
-            <a:srgbClr val="0B0F19"/>
+            <a:srgbClr val="0A0E17"/>
           </a:solidFill>
           <a:ln>
             <a:noFill/>
@@ -3349,12 +3357,12 @@
           <a:lstStyle/>
           <a:p>
             <a:r>
-              <a:rPr sz="1000" b="1">
-                <a:solidFill>
-                  <a:srgbClr val="1DB954"/>
+              <a:rPr sz="1100" b="1">
+                <a:solidFill>
+                  <a:srgbClr val="10B981"/>
                 </a:solidFill>
               </a:rPr>
-              <a:t>VISIÓN GENERAL DEL SISTEMA</a:t>
+              <a:t>PROPÓSITO DEL SISTEMA</a:t>
             </a:r>
           </a:p>
         </p:txBody>
@@ -3368,7 +3376,7 @@
         <p:spPr>
           <a:xfrm>
             <a:off x="731520" y="640080"/>
-            <a:ext cx="10698480" cy="640080"/>
+            <a:ext cx="10698480" cy="731520"/>
           </a:xfrm>
           <a:prstGeom prst="rect">
             <a:avLst/>
@@ -3382,12 +3390,12 @@
           <a:lstStyle/>
           <a:p>
             <a:r>
-              <a:rPr sz="2200" b="1">
-                <a:solidFill>
-                  <a:srgbClr val="F8FAFC"/>
+              <a:rPr sz="2500" b="1">
+                <a:solidFill>
+                  <a:srgbClr val="FFFFFF"/>
                 </a:solidFill>
               </a:rPr>
-              <a:t>Propósito de la Plataforma y Arquitectura del Sistema</a:t>
+              <a:t>Arquitectura y Valor para el Usuario</a:t>
             </a:r>
           </a:p>
         </p:txBody>
@@ -3400,18 +3408,18 @@
         </p:nvSpPr>
         <p:spPr>
           <a:xfrm>
-            <a:off x="731520" y="1371600"/>
-            <a:ext cx="4754880" cy="4937760"/>
+            <a:off x="731520" y="1463040"/>
+            <a:ext cx="4389120" cy="1417320"/>
           </a:xfrm>
           <a:prstGeom prst="roundRect">
             <a:avLst/>
           </a:prstGeom>
           <a:solidFill>
-            <a:srgbClr val="181F2E"/>
+            <a:srgbClr val="161E2E"/>
           </a:solidFill>
-          <a:ln w="12700">
+          <a:ln w="19050">
             <a:solidFill>
-              <a:srgbClr val="263047"/>
+              <a:srgbClr val="10B981"/>
             </a:solidFill>
           </a:ln>
         </p:spPr>
@@ -3445,8 +3453,8 @@
         </p:nvSpPr>
         <p:spPr>
           <a:xfrm>
-            <a:off x="914400" y="1554480"/>
-            <a:ext cx="4389120" cy="4572000"/>
+            <a:off x="914400" y="1600200"/>
+            <a:ext cx="4023360" cy="1143000"/>
           </a:xfrm>
           <a:prstGeom prst="rect">
             <a:avLst/>
@@ -3460,105 +3468,28 @@
           <a:lstStyle/>
           <a:p>
             <a:r>
-              <a:rPr sz="1400" b="1">
-                <a:solidFill>
-                  <a:srgbClr val="1DB954"/>
+              <a:rPr sz="1500" b="1">
+                <a:solidFill>
+                  <a:srgbClr val="10B981"/>
                 </a:solidFill>
               </a:rPr>
-              <a:t>¿Qué problema resuelve SoundData?
+              <a:t>🎯 Decisiones con Datos
 </a:t>
             </a:r>
           </a:p>
           <a:p>
             <a:pPr>
               <a:spcBef>
-                <a:spcPts val="800"/>
+                <a:spcPts val="400"/>
               </a:spcBef>
             </a:pPr>
             <a:r>
-              <a:rPr sz="1100" b="1">
-                <a:solidFill>
-                  <a:srgbClr val="F8FAFC"/>
+              <a:rPr sz="1300" b="0">
+                <a:solidFill>
+                  <a:srgbClr val="CBD5E1"/>
                 </a:solidFill>
               </a:rPr>
-              <a:t>• Toma de Decisiones Guiada por Datos: </a:t>
-            </a:r>
-            <a:r>
-              <a:rPr sz="1050" b="0">
-                <a:solidFill>
-                  <a:srgbClr val="94A3B8"/>
-                </a:solidFill>
-              </a:rPr>
-              <a:t>Permite a sellos y productores evaluar maquetas musicales antes de invertir en promoción.</a:t>
-            </a:r>
-          </a:p>
-          <a:p>
-            <a:pPr>
-              <a:spcBef>
-                <a:spcPts val="800"/>
-              </a:spcBef>
-            </a:pPr>
-            <a:r>
-              <a:rPr sz="1100" b="1">
-                <a:solidFill>
-                  <a:srgbClr val="F8FAFC"/>
-                </a:solidFill>
-              </a:rPr>
-              <a:t>• Simulación en Tiempo Real: </a:t>
-            </a:r>
-            <a:r>
-              <a:rPr sz="1050" b="0">
-                <a:solidFill>
-                  <a:srgbClr val="94A3B8"/>
-                </a:solidFill>
-              </a:rPr>
-              <a:t>Ajuste dinámico de parámetros acústicos (BPM, energía, bailabilidad) con inferencia instantánea.</a:t>
-            </a:r>
-          </a:p>
-          <a:p>
-            <a:pPr>
-              <a:spcBef>
-                <a:spcPts val="800"/>
-              </a:spcBef>
-            </a:pPr>
-            <a:r>
-              <a:rPr sz="1100" b="1">
-                <a:solidFill>
-                  <a:srgbClr val="F8FAFC"/>
-                </a:solidFill>
-              </a:rPr>
-              <a:t>• Persistencia de Portafolio: </a:t>
-            </a:r>
-            <a:r>
-              <a:rPr sz="1050" b="0">
-                <a:solidFill>
-                  <a:srgbClr val="94A3B8"/>
-                </a:solidFill>
-              </a:rPr>
-              <a:t>Almacenamiento corporativo de canciones analizadas con base de datos SQLite integrada.</a:t>
-            </a:r>
-          </a:p>
-          <a:p>
-            <a:pPr>
-              <a:spcBef>
-                <a:spcPts val="800"/>
-              </a:spcBef>
-            </a:pPr>
-            <a:r>
-              <a:rPr sz="1100" b="1">
-                <a:solidFill>
-                  <a:srgbClr val="F8FAFC"/>
-                </a:solidFill>
-              </a:rPr>
-              <a:t>• Arquitectura Ligera y Desacoplada: </a:t>
-            </a:r>
-            <a:r>
-              <a:rPr sz="1050" b="0">
-                <a:solidFill>
-                  <a:srgbClr val="94A3B8"/>
-                </a:solidFill>
-              </a:rPr>
-              <a:t>Frontend rápido en Bootstrap 5 consumiendo una API REST asíncrona en FastAPI.</a:t>
+              <a:t>Evaluación analítica de maquetas antes de invertir en producción musical.</a:t>
             </a:r>
           </a:p>
         </p:txBody>
@@ -3571,18 +3502,18 @@
         </p:nvSpPr>
         <p:spPr>
           <a:xfrm>
-            <a:off x="5760720" y="1371600"/>
-            <a:ext cx="5669280" cy="4937760"/>
+            <a:off x="731520" y="3063240"/>
+            <a:ext cx="4389120" cy="1417320"/>
           </a:xfrm>
           <a:prstGeom prst="roundRect">
             <a:avLst/>
           </a:prstGeom>
           <a:solidFill>
-            <a:srgbClr val="181F2E"/>
+            <a:srgbClr val="161E2E"/>
           </a:solidFill>
-          <a:ln w="12700">
+          <a:ln w="19050">
             <a:solidFill>
-              <a:srgbClr val="263047"/>
+              <a:srgbClr val="38BDF8"/>
             </a:solidFill>
           </a:ln>
         </p:spPr>
@@ -3608,9 +3539,197 @@
           </a:p>
         </p:txBody>
       </p:sp>
+      <p:sp>
+        <p:nvSpPr>
+          <p:cNvPr id="8" name="TextBox 7"/>
+          <p:cNvSpPr txBox="1"/>
+          <p:nvPr/>
+        </p:nvSpPr>
+        <p:spPr>
+          <a:xfrm>
+            <a:off x="914400" y="3200400"/>
+            <a:ext cx="4023360" cy="1143000"/>
+          </a:xfrm>
+          <a:prstGeom prst="rect">
+            <a:avLst/>
+          </a:prstGeom>
+          <a:noFill/>
+        </p:spPr>
+        <p:txBody>
+          <a:bodyPr wrap="square">
+            <a:spAutoFit/>
+          </a:bodyPr>
+          <a:lstStyle/>
+          <a:p>
+            <a:r>
+              <a:rPr sz="1500" b="1">
+                <a:solidFill>
+                  <a:srgbClr val="38BDF8"/>
+                </a:solidFill>
+              </a:rPr>
+              <a:t>⚡ Inferencia Inmediata
+</a:t>
+            </a:r>
+          </a:p>
+          <a:p>
+            <a:pPr>
+              <a:spcBef>
+                <a:spcPts val="400"/>
+              </a:spcBef>
+            </a:pPr>
+            <a:r>
+              <a:rPr sz="1300" b="0">
+                <a:solidFill>
+                  <a:srgbClr val="CBD5E1"/>
+                </a:solidFill>
+              </a:rPr>
+              <a:t>3 modelos de Machine Learning respondiendo en milisegundos.</a:t>
+            </a:r>
+          </a:p>
+        </p:txBody>
+      </p:sp>
+      <p:sp>
+        <p:nvSpPr>
+          <p:cNvPr id="9" name="Rounded Rectangle 8"/>
+          <p:cNvSpPr/>
+          <p:nvPr/>
+        </p:nvSpPr>
+        <p:spPr>
+          <a:xfrm>
+            <a:off x="731520" y="4663440"/>
+            <a:ext cx="4389120" cy="1417320"/>
+          </a:xfrm>
+          <a:prstGeom prst="roundRect">
+            <a:avLst/>
+          </a:prstGeom>
+          <a:solidFill>
+            <a:srgbClr val="161E2E"/>
+          </a:solidFill>
+          <a:ln w="19050">
+            <a:solidFill>
+              <a:srgbClr val="A855F7"/>
+            </a:solidFill>
+          </a:ln>
+        </p:spPr>
+        <p:style>
+          <a:lnRef idx="1">
+            <a:schemeClr val="accent1"/>
+          </a:lnRef>
+          <a:fillRef idx="3">
+            <a:schemeClr val="accent1"/>
+          </a:fillRef>
+          <a:effectRef idx="2">
+            <a:schemeClr val="accent1"/>
+          </a:effectRef>
+          <a:fontRef idx="minor">
+            <a:schemeClr val="lt1"/>
+          </a:fontRef>
+        </p:style>
+        <p:txBody>
+          <a:bodyPr rtlCol="0" anchor="ctr"/>
+          <a:lstStyle/>
+          <a:p>
+            <a:pPr algn="ctr"/>
+          </a:p>
+        </p:txBody>
+      </p:sp>
+      <p:sp>
+        <p:nvSpPr>
+          <p:cNvPr id="10" name="TextBox 9"/>
+          <p:cNvSpPr txBox="1"/>
+          <p:nvPr/>
+        </p:nvSpPr>
+        <p:spPr>
+          <a:xfrm>
+            <a:off x="914400" y="4800600"/>
+            <a:ext cx="4023360" cy="1143000"/>
+          </a:xfrm>
+          <a:prstGeom prst="rect">
+            <a:avLst/>
+          </a:prstGeom>
+          <a:noFill/>
+        </p:spPr>
+        <p:txBody>
+          <a:bodyPr wrap="square">
+            <a:spAutoFit/>
+          </a:bodyPr>
+          <a:lstStyle/>
+          <a:p>
+            <a:r>
+              <a:rPr sz="1500" b="1">
+                <a:solidFill>
+                  <a:srgbClr val="A855F7"/>
+                </a:solidFill>
+              </a:rPr>
+              <a:t>💾 Portafolio Transaccional
+</a:t>
+            </a:r>
+          </a:p>
+          <a:p>
+            <a:pPr>
+              <a:spcBef>
+                <a:spcPts val="400"/>
+              </a:spcBef>
+            </a:pPr>
+            <a:r>
+              <a:rPr sz="1300" b="0">
+                <a:solidFill>
+                  <a:srgbClr val="CBD5E1"/>
+                </a:solidFill>
+              </a:rPr>
+              <a:t>Base de datos SQLite integrada para gestionar canciones evaluadas.</a:t>
+            </a:r>
+          </a:p>
+        </p:txBody>
+      </p:sp>
+      <p:sp>
+        <p:nvSpPr>
+          <p:cNvPr id="11" name="Rounded Rectangle 10"/>
+          <p:cNvSpPr/>
+          <p:nvPr/>
+        </p:nvSpPr>
+        <p:spPr>
+          <a:xfrm>
+            <a:off x="5394960" y="1463040"/>
+            <a:ext cx="6035040" cy="4846320"/>
+          </a:xfrm>
+          <a:prstGeom prst="roundRect">
+            <a:avLst/>
+          </a:prstGeom>
+          <a:solidFill>
+            <a:srgbClr val="161E2E"/>
+          </a:solidFill>
+          <a:ln w="19050">
+            <a:solidFill>
+              <a:srgbClr val="2E3D59"/>
+            </a:solidFill>
+          </a:ln>
+        </p:spPr>
+        <p:style>
+          <a:lnRef idx="1">
+            <a:schemeClr val="accent1"/>
+          </a:lnRef>
+          <a:fillRef idx="3">
+            <a:schemeClr val="accent1"/>
+          </a:fillRef>
+          <a:effectRef idx="2">
+            <a:schemeClr val="accent1"/>
+          </a:effectRef>
+          <a:fontRef idx="minor">
+            <a:schemeClr val="lt1"/>
+          </a:fontRef>
+        </p:style>
+        <p:txBody>
+          <a:bodyPr rtlCol="0" anchor="ctr"/>
+          <a:lstStyle/>
+          <a:p>
+            <a:pPr algn="ctr"/>
+          </a:p>
+        </p:txBody>
+      </p:sp>
       <p:pic>
         <p:nvPicPr>
-          <p:cNvPr id="8" name="Picture 7" descr="arquitectura_sistema.png"/>
+          <p:cNvPr id="12" name="Picture 11" descr="arquitectura_sistema.png"/>
           <p:cNvPicPr>
             <a:picLocks noChangeAspect="1"/>
           </p:cNvPicPr>
@@ -3624,8 +3743,8 @@
         </p:blipFill>
         <p:spPr>
           <a:xfrm>
-            <a:off x="5897880" y="1737360"/>
-            <a:ext cx="5394960" cy="2697480"/>
+            <a:off x="5532120" y="1737360"/>
+            <a:ext cx="5760720" cy="2880360"/>
           </a:xfrm>
           <a:prstGeom prst="rect">
             <a:avLst/>
@@ -3665,7 +3784,7 @@
             <a:avLst/>
           </a:prstGeom>
           <a:solidFill>
-            <a:srgbClr val="0B0F19"/>
+            <a:srgbClr val="0A0E17"/>
           </a:solidFill>
           <a:ln>
             <a:noFill/>
@@ -3716,12 +3835,12 @@
           <a:lstStyle/>
           <a:p>
             <a:r>
-              <a:rPr sz="1000" b="1">
-                <a:solidFill>
-                  <a:srgbClr val="1DB954"/>
+              <a:rPr sz="1100" b="1">
+                <a:solidFill>
+                  <a:srgbClr val="10B981"/>
                 </a:solidFill>
               </a:rPr>
-              <a:t>VISTA 1 — DASHBOARD GENERAL</a:t>
+              <a:t>MONITOR DE AUDIENCIAS</a:t>
             </a:r>
           </a:p>
         </p:txBody>
@@ -3735,7 +3854,7 @@
         <p:spPr>
           <a:xfrm>
             <a:off x="731520" y="640080"/>
-            <a:ext cx="10698480" cy="640080"/>
+            <a:ext cx="10698480" cy="731520"/>
           </a:xfrm>
           <a:prstGeom prst="rect">
             <a:avLst/>
@@ -3749,12 +3868,12 @@
           <a:lstStyle/>
           <a:p>
             <a:r>
-              <a:rPr sz="2200" b="1">
-                <a:solidFill>
-                  <a:srgbClr val="F8FAFC"/>
+              <a:rPr sz="2500" b="1">
+                <a:solidFill>
+                  <a:srgbClr val="FFFFFF"/>
                 </a:solidFill>
               </a:rPr>
-              <a:t>Pestaña 1: Análisis Global de Oyentes y Métricas Clave</a:t>
+              <a:t>Vista 1: Análisis Global de Oyentes</a:t>
             </a:r>
           </a:p>
         </p:txBody>
@@ -3767,18 +3886,18 @@
         </p:nvSpPr>
         <p:spPr>
           <a:xfrm>
-            <a:off x="731520" y="1371600"/>
-            <a:ext cx="6858000" cy="4937760"/>
+            <a:off x="731520" y="1463040"/>
+            <a:ext cx="7132320" cy="4846320"/>
           </a:xfrm>
           <a:prstGeom prst="roundRect">
             <a:avLst/>
           </a:prstGeom>
           <a:solidFill>
-            <a:srgbClr val="181F2E"/>
+            <a:srgbClr val="161E2E"/>
           </a:solidFill>
-          <a:ln w="12700">
+          <a:ln w="19050">
             <a:solidFill>
-              <a:srgbClr val="263047"/>
+              <a:srgbClr val="2E3D59"/>
             </a:solidFill>
           </a:ln>
         </p:spPr>
@@ -3820,8 +3939,8 @@
         </p:blipFill>
         <p:spPr>
           <a:xfrm>
-            <a:off x="822960" y="1508760"/>
-            <a:ext cx="6675120" cy="3754755"/>
+            <a:off x="841248" y="1600200"/>
+            <a:ext cx="6903720" cy="3883342"/>
           </a:xfrm>
           <a:prstGeom prst="rect">
             <a:avLst/>
@@ -3836,18 +3955,18 @@
         </p:nvSpPr>
         <p:spPr>
           <a:xfrm>
-            <a:off x="7772400" y="1371600"/>
-            <a:ext cx="3657600" cy="4937760"/>
+            <a:off x="8138160" y="1463040"/>
+            <a:ext cx="3291840" cy="1417320"/>
           </a:xfrm>
           <a:prstGeom prst="roundRect">
             <a:avLst/>
           </a:prstGeom>
           <a:solidFill>
-            <a:srgbClr val="181F2E"/>
+            <a:srgbClr val="161E2E"/>
           </a:solidFill>
-          <a:ln w="12700">
+          <a:ln w="19050">
             <a:solidFill>
-              <a:srgbClr val="263047"/>
+              <a:srgbClr val="38BDF8"/>
             </a:solidFill>
           </a:ln>
         </p:spPr>
@@ -3881,8 +4000,8 @@
         </p:nvSpPr>
         <p:spPr>
           <a:xfrm>
-            <a:off x="7955279" y="1554480"/>
-            <a:ext cx="3291840" cy="4572000"/>
+            <a:off x="8321040" y="1645920"/>
+            <a:ext cx="2926080" cy="1051560"/>
           </a:xfrm>
           <a:prstGeom prst="rect">
             <a:avLst/>
@@ -3896,105 +4015,216 @@
           <a:lstStyle/>
           <a:p>
             <a:r>
-              <a:rPr sz="1400" b="1">
-                <a:solidFill>
-                  <a:srgbClr val="1DB954"/>
+              <a:rPr sz="1600" b="1">
+                <a:solidFill>
+                  <a:srgbClr val="38BDF8"/>
                 </a:solidFill>
               </a:rPr>
-              <a:t>Capacidades de la Vista:
+              <a:t>841 Millones
 </a:t>
             </a:r>
           </a:p>
           <a:p>
             <a:pPr>
               <a:spcBef>
-                <a:spcPts val="800"/>
+                <a:spcPts val="400"/>
               </a:spcBef>
             </a:pPr>
             <a:r>
-              <a:rPr sz="1050" b="1">
-                <a:solidFill>
-                  <a:srgbClr val="F8FAFC"/>
+              <a:rPr sz="1250" b="0">
+                <a:solidFill>
+                  <a:srgbClr val="CBD5E1"/>
                 </a:solidFill>
               </a:rPr>
-              <a:t>• KPIs en Tiempo Real: </a:t>
-            </a:r>
-            <a:r>
-              <a:rPr sz="1000" b="0">
-                <a:solidFill>
-                  <a:srgbClr val="94A3B8"/>
+              <a:t>Total de oyentes acumulados en el catálogo.</a:t>
+            </a:r>
+          </a:p>
+        </p:txBody>
+      </p:sp>
+      <p:sp>
+        <p:nvSpPr>
+          <p:cNvPr id="9" name="Rounded Rectangle 8"/>
+          <p:cNvSpPr/>
+          <p:nvPr/>
+        </p:nvSpPr>
+        <p:spPr>
+          <a:xfrm>
+            <a:off x="8138160" y="3063240"/>
+            <a:ext cx="3291840" cy="1417320"/>
+          </a:xfrm>
+          <a:prstGeom prst="roundRect">
+            <a:avLst/>
+          </a:prstGeom>
+          <a:solidFill>
+            <a:srgbClr val="161E2E"/>
+          </a:solidFill>
+          <a:ln w="19050">
+            <a:solidFill>
+              <a:srgbClr val="10B981"/>
+            </a:solidFill>
+          </a:ln>
+        </p:spPr>
+        <p:style>
+          <a:lnRef idx="1">
+            <a:schemeClr val="accent1"/>
+          </a:lnRef>
+          <a:fillRef idx="3">
+            <a:schemeClr val="accent1"/>
+          </a:fillRef>
+          <a:effectRef idx="2">
+            <a:schemeClr val="accent1"/>
+          </a:effectRef>
+          <a:fontRef idx="minor">
+            <a:schemeClr val="lt1"/>
+          </a:fontRef>
+        </p:style>
+        <p:txBody>
+          <a:bodyPr rtlCol="0" anchor="ctr"/>
+          <a:lstStyle/>
+          <a:p>
+            <a:pPr algn="ctr"/>
+          </a:p>
+        </p:txBody>
+      </p:sp>
+      <p:sp>
+        <p:nvSpPr>
+          <p:cNvPr id="10" name="TextBox 9"/>
+          <p:cNvSpPr txBox="1"/>
+          <p:nvPr/>
+        </p:nvSpPr>
+        <p:spPr>
+          <a:xfrm>
+            <a:off x="8321040" y="3246120"/>
+            <a:ext cx="2926080" cy="1051560"/>
+          </a:xfrm>
+          <a:prstGeom prst="rect">
+            <a:avLst/>
+          </a:prstGeom>
+          <a:noFill/>
+        </p:spPr>
+        <p:txBody>
+          <a:bodyPr wrap="square">
+            <a:spAutoFit/>
+          </a:bodyPr>
+          <a:lstStyle/>
+          <a:p>
+            <a:r>
+              <a:rPr sz="1600" b="1">
+                <a:solidFill>
+                  <a:srgbClr val="10B981"/>
                 </a:solidFill>
               </a:rPr>
-              <a:t>Muestra oyentes acumulados (841.0 M), género predominante (Clásica/Pop) y país líder en reproducciones (Alemania).</a:t>
+              <a:t>12 Géneros Musicales
+</a:t>
             </a:r>
           </a:p>
           <a:p>
             <a:pPr>
               <a:spcBef>
-                <a:spcPts val="800"/>
+                <a:spcPts val="400"/>
               </a:spcBef>
             </a:pPr>
             <a:r>
-              <a:rPr sz="1050" b="1">
-                <a:solidFill>
-                  <a:srgbClr val="F8FAFC"/>
+              <a:rPr sz="1250" b="0">
+                <a:solidFill>
+                  <a:srgbClr val="CBD5E1"/>
                 </a:solidFill>
               </a:rPr>
-              <a:t>• Gráficos Dinámicos Chart.js: </a:t>
-            </a:r>
-            <a:r>
-              <a:rPr sz="1000" b="0">
-                <a:solidFill>
-                  <a:srgbClr val="94A3B8"/>
+              <a:t>Comparativa interactiva en gráficos de barras (Chart.js).</a:t>
+            </a:r>
+          </a:p>
+        </p:txBody>
+      </p:sp>
+      <p:sp>
+        <p:nvSpPr>
+          <p:cNvPr id="11" name="Rounded Rectangle 10"/>
+          <p:cNvSpPr/>
+          <p:nvPr/>
+        </p:nvSpPr>
+        <p:spPr>
+          <a:xfrm>
+            <a:off x="8138160" y="4663440"/>
+            <a:ext cx="3291840" cy="1417320"/>
+          </a:xfrm>
+          <a:prstGeom prst="roundRect">
+            <a:avLst/>
+          </a:prstGeom>
+          <a:solidFill>
+            <a:srgbClr val="161E2E"/>
+          </a:solidFill>
+          <a:ln w="19050">
+            <a:solidFill>
+              <a:srgbClr val="F59E0B"/>
+            </a:solidFill>
+          </a:ln>
+        </p:spPr>
+        <p:style>
+          <a:lnRef idx="1">
+            <a:schemeClr val="accent1"/>
+          </a:lnRef>
+          <a:fillRef idx="3">
+            <a:schemeClr val="accent1"/>
+          </a:fillRef>
+          <a:effectRef idx="2">
+            <a:schemeClr val="accent1"/>
+          </a:effectRef>
+          <a:fontRef idx="minor">
+            <a:schemeClr val="lt1"/>
+          </a:fontRef>
+        </p:style>
+        <p:txBody>
+          <a:bodyPr rtlCol="0" anchor="ctr"/>
+          <a:lstStyle/>
+          <a:p>
+            <a:pPr algn="ctr"/>
+          </a:p>
+        </p:txBody>
+      </p:sp>
+      <p:sp>
+        <p:nvSpPr>
+          <p:cNvPr id="12" name="TextBox 11"/>
+          <p:cNvSpPr txBox="1"/>
+          <p:nvPr/>
+        </p:nvSpPr>
+        <p:spPr>
+          <a:xfrm>
+            <a:off x="8321040" y="4846320"/>
+            <a:ext cx="2926080" cy="1051560"/>
+          </a:xfrm>
+          <a:prstGeom prst="rect">
+            <a:avLst/>
+          </a:prstGeom>
+          <a:noFill/>
+        </p:spPr>
+        <p:txBody>
+          <a:bodyPr wrap="square">
+            <a:spAutoFit/>
+          </a:bodyPr>
+          <a:lstStyle/>
+          <a:p>
+            <a:r>
+              <a:rPr sz="1600" b="1">
+                <a:solidFill>
+                  <a:srgbClr val="F59E0B"/>
                 </a:solidFill>
               </a:rPr>
-              <a:t>Distribución comparativa de volumen de streams por cada uno de los 12 géneros musicales.</a:t>
+              <a:t>Cuota de Mercado
+</a:t>
             </a:r>
           </a:p>
           <a:p>
             <a:pPr>
               <a:spcBef>
-                <a:spcPts val="800"/>
+                <a:spcPts val="400"/>
               </a:spcBef>
             </a:pPr>
             <a:r>
-              <a:rPr sz="1050" b="1">
-                <a:solidFill>
-                  <a:srgbClr val="F8FAFC"/>
+              <a:rPr sz="1250" b="0">
+                <a:solidFill>
+                  <a:srgbClr val="CBD5E1"/>
                 </a:solidFill>
               </a:rPr>
-              <a:t>• Participación Territorial: </a:t>
-            </a:r>
-            <a:r>
-              <a:rPr sz="1000" b="0">
-                <a:solidFill>
-                  <a:srgbClr val="94A3B8"/>
-                </a:solidFill>
-              </a:rPr>
-              <a:t>Gráfico de dona con porcentaje de cuota de mercado por país.</a:t>
-            </a:r>
-          </a:p>
-          <a:p>
-            <a:pPr>
-              <a:spcBef>
-                <a:spcPts val="800"/>
-              </a:spcBef>
-            </a:pPr>
-            <a:r>
-              <a:rPr sz="1050" b="1">
-                <a:solidFill>
-                  <a:srgbClr val="F8FAFC"/>
-                </a:solidFill>
-              </a:rPr>
-              <a:t>• Barra de Resumen Porcentual: </a:t>
-            </a:r>
-            <a:r>
-              <a:rPr sz="1000" b="0">
-                <a:solidFill>
-                  <a:srgbClr val="94A3B8"/>
-                </a:solidFill>
-              </a:rPr>
-              <a:t>Porcentaje de penetración de oyentes ordenado por popularidad.</a:t>
+              <a:t>Distribución territorial por países en gráfico de dona.</a:t>
             </a:r>
           </a:p>
         </p:txBody>
@@ -4032,7 +4262,7 @@
             <a:avLst/>
           </a:prstGeom>
           <a:solidFill>
-            <a:srgbClr val="0B0F19"/>
+            <a:srgbClr val="0A0E17"/>
           </a:solidFill>
           <a:ln>
             <a:noFill/>
@@ -4083,12 +4313,12 @@
           <a:lstStyle/>
           <a:p>
             <a:r>
-              <a:rPr sz="1000" b="1">
-                <a:solidFill>
-                  <a:srgbClr val="1DB954"/>
+              <a:rPr sz="1100" b="1">
+                <a:solidFill>
+                  <a:srgbClr val="38BDF8"/>
                 </a:solidFill>
               </a:rPr>
-              <a:t>VISTA 2 — SEGMENTACIÓN DETALLADA</a:t>
+              <a:t>ANÁLISIS POR CATEGORÍA</a:t>
             </a:r>
           </a:p>
         </p:txBody>
@@ -4102,7 +4332,7 @@
         <p:spPr>
           <a:xfrm>
             <a:off x="731520" y="640080"/>
-            <a:ext cx="10698480" cy="640080"/>
+            <a:ext cx="10698480" cy="731520"/>
           </a:xfrm>
           <a:prstGeom prst="rect">
             <a:avLst/>
@@ -4116,12 +4346,12 @@
           <a:lstStyle/>
           <a:p>
             <a:r>
-              <a:rPr sz="2200" b="1">
-                <a:solidFill>
-                  <a:srgbClr val="F8FAFC"/>
+              <a:rPr sz="2500" b="1">
+                <a:solidFill>
+                  <a:srgbClr val="FFFFFF"/>
                 </a:solidFill>
               </a:rPr>
-              <a:t>Pestaña 2: Segmentación Univariada de Oyentes</a:t>
+              <a:t>Vista 2: Segmentación Univariada de Audiencias</a:t>
             </a:r>
           </a:p>
         </p:txBody>
@@ -4134,18 +4364,18 @@
         </p:nvSpPr>
         <p:spPr>
           <a:xfrm>
-            <a:off x="731520" y="1371600"/>
-            <a:ext cx="6858000" cy="4937760"/>
+            <a:off x="731520" y="1463040"/>
+            <a:ext cx="7132320" cy="4846320"/>
           </a:xfrm>
           <a:prstGeom prst="roundRect">
             <a:avLst/>
           </a:prstGeom>
           <a:solidFill>
-            <a:srgbClr val="181F2E"/>
+            <a:srgbClr val="161E2E"/>
           </a:solidFill>
-          <a:ln w="12700">
+          <a:ln w="19050">
             <a:solidFill>
-              <a:srgbClr val="263047"/>
+              <a:srgbClr val="2E3D59"/>
             </a:solidFill>
           </a:ln>
         </p:spPr>
@@ -4187,8 +4417,8 @@
         </p:blipFill>
         <p:spPr>
           <a:xfrm>
-            <a:off x="822960" y="1508760"/>
-            <a:ext cx="6675120" cy="3754755"/>
+            <a:off x="841248" y="1600200"/>
+            <a:ext cx="6903720" cy="3883342"/>
           </a:xfrm>
           <a:prstGeom prst="rect">
             <a:avLst/>
@@ -4203,18 +4433,18 @@
         </p:nvSpPr>
         <p:spPr>
           <a:xfrm>
-            <a:off x="7772400" y="1371600"/>
-            <a:ext cx="3657600" cy="4937760"/>
+            <a:off x="8138160" y="1463040"/>
+            <a:ext cx="3291840" cy="1417320"/>
           </a:xfrm>
           <a:prstGeom prst="roundRect">
             <a:avLst/>
           </a:prstGeom>
           <a:solidFill>
-            <a:srgbClr val="181F2E"/>
+            <a:srgbClr val="161E2E"/>
           </a:solidFill>
-          <a:ln w="12700">
+          <a:ln w="19050">
             <a:solidFill>
-              <a:srgbClr val="263047"/>
+              <a:srgbClr val="38BDF8"/>
             </a:solidFill>
           </a:ln>
         </p:spPr>
@@ -4248,8 +4478,8 @@
         </p:nvSpPr>
         <p:spPr>
           <a:xfrm>
-            <a:off x="7955279" y="1554480"/>
-            <a:ext cx="3291840" cy="4572000"/>
+            <a:off x="8321040" y="1645920"/>
+            <a:ext cx="2926080" cy="1051560"/>
           </a:xfrm>
           <a:prstGeom prst="rect">
             <a:avLst/>
@@ -4263,105 +4493,216 @@
           <a:lstStyle/>
           <a:p>
             <a:r>
-              <a:rPr sz="1400" b="1">
-                <a:solidFill>
-                  <a:srgbClr val="1DB954"/>
+              <a:rPr sz="1500" b="1">
+                <a:solidFill>
+                  <a:srgbClr val="38BDF8"/>
                 </a:solidFill>
               </a:rPr>
-              <a:t>Filtros y Segmentación:
+              <a:t>7 Selectores Dinámicos
 </a:t>
             </a:r>
           </a:p>
           <a:p>
             <a:pPr>
               <a:spcBef>
-                <a:spcPts val="800"/>
+                <a:spcPts val="400"/>
               </a:spcBef>
             </a:pPr>
             <a:r>
-              <a:rPr sz="1050" b="1">
-                <a:solidFill>
-                  <a:srgbClr val="F8FAFC"/>
+              <a:rPr sz="1250" b="0">
+                <a:solidFill>
+                  <a:srgbClr val="CBD5E1"/>
                 </a:solidFill>
               </a:rPr>
-              <a:t>• Selectores por Pill (100% Español): </a:t>
-            </a:r>
-            <a:r>
-              <a:rPr sz="1000" b="0">
-                <a:solidFill>
-                  <a:srgbClr val="94A3B8"/>
+              <a:t>Filtro rápido por Género, País, Año, Popularidad, Bailabilidad y Energía.</a:t>
+            </a:r>
+          </a:p>
+        </p:txBody>
+      </p:sp>
+      <p:sp>
+        <p:nvSpPr>
+          <p:cNvPr id="9" name="Rounded Rectangle 8"/>
+          <p:cNvSpPr/>
+          <p:nvPr/>
+        </p:nvSpPr>
+        <p:spPr>
+          <a:xfrm>
+            <a:off x="8138160" y="3063240"/>
+            <a:ext cx="3291840" cy="1417320"/>
+          </a:xfrm>
+          <a:prstGeom prst="roundRect">
+            <a:avLst/>
+          </a:prstGeom>
+          <a:solidFill>
+            <a:srgbClr val="161E2E"/>
+          </a:solidFill>
+          <a:ln w="19050">
+            <a:solidFill>
+              <a:srgbClr val="10B981"/>
+            </a:solidFill>
+          </a:ln>
+        </p:spPr>
+        <p:style>
+          <a:lnRef idx="1">
+            <a:schemeClr val="accent1"/>
+          </a:lnRef>
+          <a:fillRef idx="3">
+            <a:schemeClr val="accent1"/>
+          </a:fillRef>
+          <a:effectRef idx="2">
+            <a:schemeClr val="accent1"/>
+          </a:effectRef>
+          <a:fontRef idx="minor">
+            <a:schemeClr val="lt1"/>
+          </a:fontRef>
+        </p:style>
+        <p:txBody>
+          <a:bodyPr rtlCol="0" anchor="ctr"/>
+          <a:lstStyle/>
+          <a:p>
+            <a:pPr algn="ctr"/>
+          </a:p>
+        </p:txBody>
+      </p:sp>
+      <p:sp>
+        <p:nvSpPr>
+          <p:cNvPr id="10" name="TextBox 9"/>
+          <p:cNvSpPr txBox="1"/>
+          <p:nvPr/>
+        </p:nvSpPr>
+        <p:spPr>
+          <a:xfrm>
+            <a:off x="8321040" y="3246120"/>
+            <a:ext cx="2926080" cy="1051560"/>
+          </a:xfrm>
+          <a:prstGeom prst="rect">
+            <a:avLst/>
+          </a:prstGeom>
+          <a:noFill/>
+        </p:spPr>
+        <p:txBody>
+          <a:bodyPr wrap="square">
+            <a:spAutoFit/>
+          </a:bodyPr>
+          <a:lstStyle/>
+          <a:p>
+            <a:r>
+              <a:rPr sz="1500" b="1">
+                <a:solidFill>
+                  <a:srgbClr val="10B981"/>
                 </a:solidFill>
               </a:rPr>
-              <a:t>Permite segmentar con un clic por Género, País, Año de Lanzamiento, Popularidad, Bailabilidad, Energía y Contenido Explícito.</a:t>
+              <a:t>Tabla de Penetración
+</a:t>
             </a:r>
           </a:p>
           <a:p>
             <a:pPr>
               <a:spcBef>
-                <a:spcPts val="800"/>
+                <a:spcPts val="400"/>
               </a:spcBef>
             </a:pPr>
             <a:r>
-              <a:rPr sz="1050" b="1">
-                <a:solidFill>
-                  <a:srgbClr val="F8FAFC"/>
+              <a:rPr sz="1250" b="0">
+                <a:solidFill>
+                  <a:srgbClr val="CBD5E1"/>
                 </a:solidFill>
               </a:rPr>
-              <a:t>• Conteo de Categorías: </a:t>
-            </a:r>
-            <a:r>
-              <a:rPr sz="1000" b="0">
-                <a:solidFill>
-                  <a:srgbClr val="94A3B8"/>
+              <a:t>Cálculo en tiempo real del porcentaje de peso de cada segmento.</a:t>
+            </a:r>
+          </a:p>
+        </p:txBody>
+      </p:sp>
+      <p:sp>
+        <p:nvSpPr>
+          <p:cNvPr id="11" name="Rounded Rectangle 10"/>
+          <p:cNvSpPr/>
+          <p:nvPr/>
+        </p:nvSpPr>
+        <p:spPr>
+          <a:xfrm>
+            <a:off x="8138160" y="4663440"/>
+            <a:ext cx="3291840" cy="1417320"/>
+          </a:xfrm>
+          <a:prstGeom prst="roundRect">
+            <a:avLst/>
+          </a:prstGeom>
+          <a:solidFill>
+            <a:srgbClr val="161E2E"/>
+          </a:solidFill>
+          <a:ln w="19050">
+            <a:solidFill>
+              <a:srgbClr val="F59E0B"/>
+            </a:solidFill>
+          </a:ln>
+        </p:spPr>
+        <p:style>
+          <a:lnRef idx="1">
+            <a:schemeClr val="accent1"/>
+          </a:lnRef>
+          <a:fillRef idx="3">
+            <a:schemeClr val="accent1"/>
+          </a:fillRef>
+          <a:effectRef idx="2">
+            <a:schemeClr val="accent1"/>
+          </a:effectRef>
+          <a:fontRef idx="minor">
+            <a:schemeClr val="lt1"/>
+          </a:fontRef>
+        </p:style>
+        <p:txBody>
+          <a:bodyPr rtlCol="0" anchor="ctr"/>
+          <a:lstStyle/>
+          <a:p>
+            <a:pPr algn="ctr"/>
+          </a:p>
+        </p:txBody>
+      </p:sp>
+      <p:sp>
+        <p:nvSpPr>
+          <p:cNvPr id="12" name="TextBox 11"/>
+          <p:cNvSpPr txBox="1"/>
+          <p:nvPr/>
+        </p:nvSpPr>
+        <p:spPr>
+          <a:xfrm>
+            <a:off x="8321040" y="4846320"/>
+            <a:ext cx="2926080" cy="1051560"/>
+          </a:xfrm>
+          <a:prstGeom prst="rect">
+            <a:avLst/>
+          </a:prstGeom>
+          <a:noFill/>
+        </p:spPr>
+        <p:txBody>
+          <a:bodyPr wrap="square">
+            <a:spAutoFit/>
+          </a:bodyPr>
+          <a:lstStyle/>
+          <a:p>
+            <a:r>
+              <a:rPr sz="1500" b="1">
+                <a:solidFill>
+                  <a:srgbClr val="F59E0B"/>
                 </a:solidFill>
               </a:rPr>
-              <a:t>Cálculo instantáneo de millones de oyentes y porcentaje de peso de cada grupo.</a:t>
+              <a:t>Descarga en 1 Clic
+</a:t>
             </a:r>
           </a:p>
           <a:p>
             <a:pPr>
               <a:spcBef>
-                <a:spcPts val="800"/>
+                <a:spcPts val="400"/>
               </a:spcBef>
             </a:pPr>
             <a:r>
-              <a:rPr sz="1050" b="1">
-                <a:solidFill>
-                  <a:srgbClr val="F8FAFC"/>
+              <a:rPr sz="1250" b="0">
+                <a:solidFill>
+                  <a:srgbClr val="CBD5E1"/>
                 </a:solidFill>
               </a:rPr>
-              <a:t>• Tabla de Participación: </a:t>
-            </a:r>
-            <a:r>
-              <a:rPr sz="1000" b="0">
-                <a:solidFill>
-                  <a:srgbClr val="94A3B8"/>
-                </a:solidFill>
-              </a:rPr>
-              <a:t>Visualización ordenada de penetración sobre los 85.000 registros.</a:t>
-            </a:r>
-          </a:p>
-          <a:p>
-            <a:pPr>
-              <a:spcBef>
-                <a:spcPts val="800"/>
-              </a:spcBef>
-            </a:pPr>
-            <a:r>
-              <a:rPr sz="1050" b="1">
-                <a:solidFill>
-                  <a:srgbClr val="F8FAFC"/>
-                </a:solidFill>
-              </a:rPr>
-              <a:t>• Exportación JSON: </a:t>
-            </a:r>
-            <a:r>
-              <a:rPr sz="1000" b="0">
-                <a:solidFill>
-                  <a:srgbClr val="94A3B8"/>
-                </a:solidFill>
-              </a:rPr>
-              <a:t>Botón para exportar el resumen analítico filtrado para su uso en reportes ejecutivos.</a:t>
+              <a:t>Botón para exportar el resumen analítico estructurado en JSON.</a:t>
             </a:r>
           </a:p>
         </p:txBody>
@@ -4399,7 +4740,7 @@
             <a:avLst/>
           </a:prstGeom>
           <a:solidFill>
-            <a:srgbClr val="0B0F19"/>
+            <a:srgbClr val="0A0E17"/>
           </a:solidFill>
           <a:ln>
             <a:noFill/>
@@ -4450,12 +4791,12 @@
           <a:lstStyle/>
           <a:p>
             <a:r>
-              <a:rPr sz="1000" b="1">
-                <a:solidFill>
-                  <a:srgbClr val="1DB954"/>
+              <a:rPr sz="1100" b="1">
+                <a:solidFill>
+                  <a:srgbClr val="10B981"/>
                 </a:solidFill>
               </a:rPr>
-              <a:t>VISTA 3 — MOTOR DE INFERENCIA</a:t>
+              <a:t>MOTOR DE INFERENCIA EN VIVO</a:t>
             </a:r>
           </a:p>
         </p:txBody>
@@ -4469,7 +4810,7 @@
         <p:spPr>
           <a:xfrm>
             <a:off x="731520" y="640080"/>
-            <a:ext cx="10698480" cy="640080"/>
+            <a:ext cx="10698480" cy="731520"/>
           </a:xfrm>
           <a:prstGeom prst="rect">
             <a:avLst/>
@@ -4483,12 +4824,12 @@
           <a:lstStyle/>
           <a:p>
             <a:r>
-              <a:rPr sz="2200" b="1">
-                <a:solidFill>
-                  <a:srgbClr val="F8FAFC"/>
+              <a:rPr sz="2500" b="1">
+                <a:solidFill>
+                  <a:srgbClr val="FFFFFF"/>
                 </a:solidFill>
               </a:rPr>
-              <a:t>Pestaña 3: Simulador de Éxito en Tiempo Real (Machine Learning)</a:t>
+              <a:t>Vista 3: Simulador Predictivo con Machine Learning</a:t>
             </a:r>
           </a:p>
         </p:txBody>
@@ -4501,18 +4842,18 @@
         </p:nvSpPr>
         <p:spPr>
           <a:xfrm>
-            <a:off x="731520" y="1371600"/>
-            <a:ext cx="6858000" cy="4937760"/>
+            <a:off x="731520" y="1463040"/>
+            <a:ext cx="7132320" cy="4846320"/>
           </a:xfrm>
           <a:prstGeom prst="roundRect">
             <a:avLst/>
           </a:prstGeom>
           <a:solidFill>
-            <a:srgbClr val="181F2E"/>
+            <a:srgbClr val="161E2E"/>
           </a:solidFill>
-          <a:ln w="12700">
+          <a:ln w="19050">
             <a:solidFill>
-              <a:srgbClr val="263047"/>
+              <a:srgbClr val="2E3D59"/>
             </a:solidFill>
           </a:ln>
         </p:spPr>
@@ -4554,8 +4895,8 @@
         </p:blipFill>
         <p:spPr>
           <a:xfrm>
-            <a:off x="822960" y="1508760"/>
-            <a:ext cx="6675120" cy="3754755"/>
+            <a:off x="841248" y="1600200"/>
+            <a:ext cx="6903720" cy="3883342"/>
           </a:xfrm>
           <a:prstGeom prst="rect">
             <a:avLst/>
@@ -4570,18 +4911,18 @@
         </p:nvSpPr>
         <p:spPr>
           <a:xfrm>
-            <a:off x="7772400" y="1371600"/>
-            <a:ext cx="3657600" cy="4937760"/>
+            <a:off x="8138160" y="1463040"/>
+            <a:ext cx="3291840" cy="1417320"/>
           </a:xfrm>
           <a:prstGeom prst="roundRect">
             <a:avLst/>
           </a:prstGeom>
           <a:solidFill>
-            <a:srgbClr val="181F2E"/>
+            <a:srgbClr val="161E2E"/>
           </a:solidFill>
-          <a:ln w="12700">
+          <a:ln w="19050">
             <a:solidFill>
-              <a:srgbClr val="263047"/>
+              <a:srgbClr val="38BDF8"/>
             </a:solidFill>
           </a:ln>
         </p:spPr>
@@ -4615,8 +4956,8 @@
         </p:nvSpPr>
         <p:spPr>
           <a:xfrm>
-            <a:off x="7955279" y="1554480"/>
-            <a:ext cx="3291840" cy="4572000"/>
+            <a:off x="8321040" y="1645920"/>
+            <a:ext cx="2926080" cy="1051560"/>
           </a:xfrm>
           <a:prstGeom prst="rect">
             <a:avLst/>
@@ -4630,128 +4971,216 @@
           <a:lstStyle/>
           <a:p>
             <a:r>
-              <a:rPr sz="1400" b="1">
-                <a:solidFill>
-                  <a:srgbClr val="1DB954"/>
+              <a:rPr sz="1500" b="1">
+                <a:solidFill>
+                  <a:srgbClr val="38BDF8"/>
                 </a:solidFill>
               </a:rPr>
-              <a:t>Inferencia Triple Unificada:
+              <a:t>🎛️ Sliders Acústicos
 </a:t>
             </a:r>
           </a:p>
           <a:p>
             <a:pPr>
               <a:spcBef>
-                <a:spcPts val="600"/>
+                <a:spcPts val="400"/>
               </a:spcBef>
             </a:pPr>
             <a:r>
-              <a:rPr sz="1000" b="1">
-                <a:solidFill>
-                  <a:srgbClr val="F8FAFC"/>
+              <a:rPr sz="1250" b="0">
+                <a:solidFill>
+                  <a:srgbClr val="CBD5E1"/>
                 </a:solidFill>
               </a:rPr>
-              <a:t>• Control Acústico Intuitivo: </a:t>
-            </a:r>
-            <a:r>
-              <a:rPr sz="950" b="0">
-                <a:solidFill>
-                  <a:srgbClr val="94A3B8"/>
+              <a:t>Ajuste en vivo de BPM, Energía, Sonoridad, Bailabilidad e Instrumentalidad.</a:t>
+            </a:r>
+          </a:p>
+        </p:txBody>
+      </p:sp>
+      <p:sp>
+        <p:nvSpPr>
+          <p:cNvPr id="9" name="Rounded Rectangle 8"/>
+          <p:cNvSpPr/>
+          <p:nvPr/>
+        </p:nvSpPr>
+        <p:spPr>
+          <a:xfrm>
+            <a:off x="8138160" y="3063240"/>
+            <a:ext cx="3291840" cy="1417320"/>
+          </a:xfrm>
+          <a:prstGeom prst="roundRect">
+            <a:avLst/>
+          </a:prstGeom>
+          <a:solidFill>
+            <a:srgbClr val="161E2E"/>
+          </a:solidFill>
+          <a:ln w="19050">
+            <a:solidFill>
+              <a:srgbClr val="10B981"/>
+            </a:solidFill>
+          </a:ln>
+        </p:spPr>
+        <p:style>
+          <a:lnRef idx="1">
+            <a:schemeClr val="accent1"/>
+          </a:lnRef>
+          <a:fillRef idx="3">
+            <a:schemeClr val="accent1"/>
+          </a:fillRef>
+          <a:effectRef idx="2">
+            <a:schemeClr val="accent1"/>
+          </a:effectRef>
+          <a:fontRef idx="minor">
+            <a:schemeClr val="lt1"/>
+          </a:fontRef>
+        </p:style>
+        <p:txBody>
+          <a:bodyPr rtlCol="0" anchor="ctr"/>
+          <a:lstStyle/>
+          <a:p>
+            <a:pPr algn="ctr"/>
+          </a:p>
+        </p:txBody>
+      </p:sp>
+      <p:sp>
+        <p:nvSpPr>
+          <p:cNvPr id="10" name="TextBox 9"/>
+          <p:cNvSpPr txBox="1"/>
+          <p:nvPr/>
+        </p:nvSpPr>
+        <p:spPr>
+          <a:xfrm>
+            <a:off x="8321040" y="3246120"/>
+            <a:ext cx="2926080" cy="1051560"/>
+          </a:xfrm>
+          <a:prstGeom prst="rect">
+            <a:avLst/>
+          </a:prstGeom>
+          <a:noFill/>
+        </p:spPr>
+        <p:txBody>
+          <a:bodyPr wrap="square">
+            <a:spAutoFit/>
+          </a:bodyPr>
+          <a:lstStyle/>
+          <a:p>
+            <a:r>
+              <a:rPr sz="1500" b="1">
+                <a:solidFill>
+                  <a:srgbClr val="10B981"/>
                 </a:solidFill>
               </a:rPr>
-              <a:t>Deslizadores en tiempo real para BPM (50-220), Energía, Bailabilidad, Sonoridad (dB) e Instrumentalidad.</a:t>
+              <a:t>🧠 Triple Diagnóstico
+</a:t>
             </a:r>
           </a:p>
           <a:p>
             <a:pPr>
               <a:spcBef>
-                <a:spcPts val="600"/>
+                <a:spcPts val="400"/>
               </a:spcBef>
             </a:pPr>
             <a:r>
-              <a:rPr sz="1000" b="1">
-                <a:solidFill>
-                  <a:srgbClr val="F8FAFC"/>
+              <a:rPr sz="1250" b="0">
+                <a:solidFill>
+                  <a:srgbClr val="CBD5E1"/>
                 </a:solidFill>
               </a:rPr>
-              <a:t>• Modelo 1 (Árbol de Decisión): </a:t>
-            </a:r>
-            <a:r>
-              <a:rPr sz="950" b="0">
-                <a:solidFill>
-                  <a:srgbClr val="94A3B8"/>
+              <a:t>Predicción de Hit (Árbol) + Clúster Sonoro (K-Means) + Afinidad (Apriori).</a:t>
+            </a:r>
+          </a:p>
+        </p:txBody>
+      </p:sp>
+      <p:sp>
+        <p:nvSpPr>
+          <p:cNvPr id="11" name="Rounded Rectangle 10"/>
+          <p:cNvSpPr/>
+          <p:nvPr/>
+        </p:nvSpPr>
+        <p:spPr>
+          <a:xfrm>
+            <a:off x="8138160" y="4663440"/>
+            <a:ext cx="3291840" cy="1417320"/>
+          </a:xfrm>
+          <a:prstGeom prst="roundRect">
+            <a:avLst/>
+          </a:prstGeom>
+          <a:solidFill>
+            <a:srgbClr val="161E2E"/>
+          </a:solidFill>
+          <a:ln w="19050">
+            <a:solidFill>
+              <a:srgbClr val="A855F7"/>
+            </a:solidFill>
+          </a:ln>
+        </p:spPr>
+        <p:style>
+          <a:lnRef idx="1">
+            <a:schemeClr val="accent1"/>
+          </a:lnRef>
+          <a:fillRef idx="3">
+            <a:schemeClr val="accent1"/>
+          </a:fillRef>
+          <a:effectRef idx="2">
+            <a:schemeClr val="accent1"/>
+          </a:effectRef>
+          <a:fontRef idx="minor">
+            <a:schemeClr val="lt1"/>
+          </a:fontRef>
+        </p:style>
+        <p:txBody>
+          <a:bodyPr rtlCol="0" anchor="ctr"/>
+          <a:lstStyle/>
+          <a:p>
+            <a:pPr algn="ctr"/>
+          </a:p>
+        </p:txBody>
+      </p:sp>
+      <p:sp>
+        <p:nvSpPr>
+          <p:cNvPr id="12" name="TextBox 11"/>
+          <p:cNvSpPr txBox="1"/>
+          <p:nvPr/>
+        </p:nvSpPr>
+        <p:spPr>
+          <a:xfrm>
+            <a:off x="8321040" y="4846320"/>
+            <a:ext cx="2926080" cy="1051560"/>
+          </a:xfrm>
+          <a:prstGeom prst="rect">
+            <a:avLst/>
+          </a:prstGeom>
+          <a:noFill/>
+        </p:spPr>
+        <p:txBody>
+          <a:bodyPr wrap="square">
+            <a:spAutoFit/>
+          </a:bodyPr>
+          <a:lstStyle/>
+          <a:p>
+            <a:r>
+              <a:rPr sz="1500" b="1">
+                <a:solidFill>
+                  <a:srgbClr val="A855F7"/>
                 </a:solidFill>
               </a:rPr>
-              <a:t>Predice si la canción alcanzará el Top 25% de streams y entrega la probabilidad porcentual estimada.</a:t>
+              <a:t>💾 Guardar en Portafolio
+</a:t>
             </a:r>
           </a:p>
           <a:p>
             <a:pPr>
               <a:spcBef>
-                <a:spcPts val="600"/>
+                <a:spcPts val="400"/>
               </a:spcBef>
             </a:pPr>
             <a:r>
-              <a:rPr sz="1000" b="1">
-                <a:solidFill>
-                  <a:srgbClr val="F8FAFC"/>
+              <a:rPr sz="1250" b="0">
+                <a:solidFill>
+                  <a:srgbClr val="CBD5E1"/>
                 </a:solidFill>
               </a:rPr>
-              <a:t>• Modelo 2 (K-Means Clustering): </a:t>
-            </a:r>
-            <a:r>
-              <a:rPr sz="950" b="0">
-                <a:solidFill>
-                  <a:srgbClr val="94A3B8"/>
-                </a:solidFill>
-              </a:rPr>
-              <a:t>Clasifica el tema en uno de los 4 arquetipos sonoros (Pop Radio, Chill, Rock/Fiesta o Urbano).</a:t>
-            </a:r>
-          </a:p>
-          <a:p>
-            <a:pPr>
-              <a:spcBef>
-                <a:spcPts val="600"/>
-              </a:spcBef>
-            </a:pPr>
-            <a:r>
-              <a:rPr sz="1000" b="1">
-                <a:solidFill>
-                  <a:srgbClr val="F8FAFC"/>
-                </a:solidFill>
-              </a:rPr>
-              <a:t>• Modelo 3 (Reglas Apriori): </a:t>
-            </a:r>
-            <a:r>
-              <a:rPr sz="950" b="0">
-                <a:solidFill>
-                  <a:srgbClr val="94A3B8"/>
-                </a:solidFill>
-              </a:rPr>
-              <a:t>Entrega recomendaciones accionables de afinidad de género y mercado.</a:t>
-            </a:r>
-          </a:p>
-          <a:p>
-            <a:pPr>
-              <a:spcBef>
-                <a:spcPts val="600"/>
-              </a:spcBef>
-            </a:pPr>
-            <a:r>
-              <a:rPr sz="1000" b="1">
-                <a:solidFill>
-                  <a:srgbClr val="F8FAFC"/>
-                </a:solidFill>
-              </a:rPr>
-              <a:t>• Guardado en Portafolio: </a:t>
-            </a:r>
-            <a:r>
-              <a:rPr sz="950" b="0">
-                <a:solidFill>
-                  <a:srgbClr val="94A3B8"/>
-                </a:solidFill>
-              </a:rPr>
-              <a:t>Botón directo para registrar el demo evaluado en SQLite sin recargar la página.</a:t>
+              <a:t>Registro directo de la canción evaluada en SQLite con un solo clic.</a:t>
             </a:r>
           </a:p>
         </p:txBody>
@@ -4789,7 +5218,7 @@
             <a:avLst/>
           </a:prstGeom>
           <a:solidFill>
-            <a:srgbClr val="0B0F19"/>
+            <a:srgbClr val="0A0E17"/>
           </a:solidFill>
           <a:ln>
             <a:noFill/>
@@ -4840,12 +5269,12 @@
           <a:lstStyle/>
           <a:p>
             <a:r>
-              <a:rPr sz="1000" b="1">
-                <a:solidFill>
-                  <a:srgbClr val="1DB954"/>
+              <a:rPr sz="1100" b="1">
+                <a:solidFill>
+                  <a:srgbClr val="A855F7"/>
                 </a:solidFill>
               </a:rPr>
-              <a:t>VISTA 4 — PERSISTENCIA Y ADMINISTRACIÓN</a:t>
+              <a:t>ADMINISTRACIÓN Y PERSISTENCIA</a:t>
             </a:r>
           </a:p>
         </p:txBody>
@@ -4859,7 +5288,7 @@
         <p:spPr>
           <a:xfrm>
             <a:off x="731520" y="640080"/>
-            <a:ext cx="10698480" cy="640080"/>
+            <a:ext cx="10698480" cy="731520"/>
           </a:xfrm>
           <a:prstGeom prst="rect">
             <a:avLst/>
@@ -4873,12 +5302,12 @@
           <a:lstStyle/>
           <a:p>
             <a:r>
-              <a:rPr sz="2200" b="1">
-                <a:solidFill>
-                  <a:srgbClr val="F8FAFC"/>
+              <a:rPr sz="2500" b="1">
+                <a:solidFill>
+                  <a:srgbClr val="FFFFFF"/>
                 </a:solidFill>
               </a:rPr>
-              <a:t>Pestaña 4: Portafolio de Canciones &amp; Gestión CRUD (SQLite)</a:t>
+              <a:t>Vista 4: Portafolio de Canciones &amp; Gestión CRUD</a:t>
             </a:r>
           </a:p>
         </p:txBody>
@@ -4891,18 +5320,18 @@
         </p:nvSpPr>
         <p:spPr>
           <a:xfrm>
-            <a:off x="731520" y="1371600"/>
-            <a:ext cx="6858000" cy="4937760"/>
+            <a:off x="731520" y="1463040"/>
+            <a:ext cx="7132320" cy="4846320"/>
           </a:xfrm>
           <a:prstGeom prst="roundRect">
             <a:avLst/>
           </a:prstGeom>
           <a:solidFill>
-            <a:srgbClr val="181F2E"/>
+            <a:srgbClr val="161E2E"/>
           </a:solidFill>
-          <a:ln w="12700">
+          <a:ln w="19050">
             <a:solidFill>
-              <a:srgbClr val="263047"/>
+              <a:srgbClr val="2E3D59"/>
             </a:solidFill>
           </a:ln>
         </p:spPr>
@@ -4944,8 +5373,8 @@
         </p:blipFill>
         <p:spPr>
           <a:xfrm>
-            <a:off x="822960" y="1508760"/>
-            <a:ext cx="6675120" cy="3754755"/>
+            <a:off x="841248" y="1600200"/>
+            <a:ext cx="6903720" cy="3883342"/>
           </a:xfrm>
           <a:prstGeom prst="rect">
             <a:avLst/>
@@ -4960,18 +5389,18 @@
         </p:nvSpPr>
         <p:spPr>
           <a:xfrm>
-            <a:off x="7772400" y="1371600"/>
-            <a:ext cx="3657600" cy="4937760"/>
+            <a:off x="8138160" y="1463040"/>
+            <a:ext cx="3291840" cy="1417320"/>
           </a:xfrm>
           <a:prstGeom prst="roundRect">
             <a:avLst/>
           </a:prstGeom>
           <a:solidFill>
-            <a:srgbClr val="181F2E"/>
+            <a:srgbClr val="161E2E"/>
           </a:solidFill>
-          <a:ln w="12700">
+          <a:ln w="19050">
             <a:solidFill>
-              <a:srgbClr val="263047"/>
+              <a:srgbClr val="A855F7"/>
             </a:solidFill>
           </a:ln>
         </p:spPr>
@@ -5005,8 +5434,8 @@
         </p:nvSpPr>
         <p:spPr>
           <a:xfrm>
-            <a:off x="7955279" y="1554480"/>
-            <a:ext cx="3291840" cy="4572000"/>
+            <a:off x="8321040" y="1645920"/>
+            <a:ext cx="2926080" cy="1051560"/>
           </a:xfrm>
           <a:prstGeom prst="rect">
             <a:avLst/>
@@ -5020,105 +5449,216 @@
           <a:lstStyle/>
           <a:p>
             <a:r>
-              <a:rPr sz="1400" b="1">
-                <a:solidFill>
-                  <a:srgbClr val="1DB954"/>
+              <a:rPr sz="1500" b="1">
+                <a:solidFill>
+                  <a:srgbClr val="A855F7"/>
                 </a:solidFill>
               </a:rPr>
-              <a:t>Funciones Transaccionales:
+              <a:t>Base de Datos SQLite
 </a:t>
             </a:r>
           </a:p>
           <a:p>
             <a:pPr>
               <a:spcBef>
-                <a:spcPts val="800"/>
+                <a:spcPts val="400"/>
               </a:spcBef>
             </a:pPr>
             <a:r>
-              <a:rPr sz="1050" b="1">
-                <a:solidFill>
-                  <a:srgbClr val="F8FAFC"/>
+              <a:rPr sz="1250" b="0">
+                <a:solidFill>
+                  <a:srgbClr val="CBD5E1"/>
                 </a:solidFill>
               </a:rPr>
-              <a:t>• Persistencia Real (SQLite 3): </a:t>
-            </a:r>
-            <a:r>
-              <a:rPr sz="1000" b="0">
-                <a:solidFill>
-                  <a:srgbClr val="94A3B8"/>
+              <a:t>Persistencia segura y liviana mediante la base de datos 'sounddata.db'.</a:t>
+            </a:r>
+          </a:p>
+        </p:txBody>
+      </p:sp>
+      <p:sp>
+        <p:nvSpPr>
+          <p:cNvPr id="9" name="Rounded Rectangle 8"/>
+          <p:cNvSpPr/>
+          <p:nvPr/>
+        </p:nvSpPr>
+        <p:spPr>
+          <a:xfrm>
+            <a:off x="8138160" y="3063240"/>
+            <a:ext cx="3291840" cy="1417320"/>
+          </a:xfrm>
+          <a:prstGeom prst="roundRect">
+            <a:avLst/>
+          </a:prstGeom>
+          <a:solidFill>
+            <a:srgbClr val="161E2E"/>
+          </a:solidFill>
+          <a:ln w="19050">
+            <a:solidFill>
+              <a:srgbClr val="10B981"/>
+            </a:solidFill>
+          </a:ln>
+        </p:spPr>
+        <p:style>
+          <a:lnRef idx="1">
+            <a:schemeClr val="accent1"/>
+          </a:lnRef>
+          <a:fillRef idx="3">
+            <a:schemeClr val="accent1"/>
+          </a:fillRef>
+          <a:effectRef idx="2">
+            <a:schemeClr val="accent1"/>
+          </a:effectRef>
+          <a:fontRef idx="minor">
+            <a:schemeClr val="lt1"/>
+          </a:fontRef>
+        </p:style>
+        <p:txBody>
+          <a:bodyPr rtlCol="0" anchor="ctr"/>
+          <a:lstStyle/>
+          <a:p>
+            <a:pPr algn="ctr"/>
+          </a:p>
+        </p:txBody>
+      </p:sp>
+      <p:sp>
+        <p:nvSpPr>
+          <p:cNvPr id="10" name="TextBox 9"/>
+          <p:cNvSpPr txBox="1"/>
+          <p:nvPr/>
+        </p:nvSpPr>
+        <p:spPr>
+          <a:xfrm>
+            <a:off x="8321040" y="3246120"/>
+            <a:ext cx="2926080" cy="1051560"/>
+          </a:xfrm>
+          <a:prstGeom prst="rect">
+            <a:avLst/>
+          </a:prstGeom>
+          <a:noFill/>
+        </p:spPr>
+        <p:txBody>
+          <a:bodyPr wrap="square">
+            <a:spAutoFit/>
+          </a:bodyPr>
+          <a:lstStyle/>
+          <a:p>
+            <a:r>
+              <a:rPr sz="1500" b="1">
+                <a:solidFill>
+                  <a:srgbClr val="10B981"/>
                 </a:solidFill>
               </a:rPr>
-              <a:t>Base de datos relacional 'sounddata.db' que preserva el catálogo y los demos evaluados.</a:t>
+              <a:t>Operaciones Completas
+</a:t>
             </a:r>
           </a:p>
           <a:p>
             <a:pPr>
               <a:spcBef>
-                <a:spcPts val="800"/>
+                <a:spcPts val="400"/>
               </a:spcBef>
             </a:pPr>
             <a:r>
-              <a:rPr sz="1050" b="1">
-                <a:solidFill>
-                  <a:srgbClr val="F8FAFC"/>
+              <a:rPr sz="1250" b="0">
+                <a:solidFill>
+                  <a:srgbClr val="CBD5E1"/>
                 </a:solidFill>
               </a:rPr>
-              <a:t>• Operaciones CRUD Completas: </a:t>
-            </a:r>
-            <a:r>
-              <a:rPr sz="1000" b="0">
-                <a:solidFill>
-                  <a:srgbClr val="94A3B8"/>
+              <a:t>Creación manual, edición modal, filtrado por género y eliminación.</a:t>
+            </a:r>
+          </a:p>
+        </p:txBody>
+      </p:sp>
+      <p:sp>
+        <p:nvSpPr>
+          <p:cNvPr id="11" name="Rounded Rectangle 10"/>
+          <p:cNvSpPr/>
+          <p:nvPr/>
+        </p:nvSpPr>
+        <p:spPr>
+          <a:xfrm>
+            <a:off x="8138160" y="4663440"/>
+            <a:ext cx="3291840" cy="1417320"/>
+          </a:xfrm>
+          <a:prstGeom prst="roundRect">
+            <a:avLst/>
+          </a:prstGeom>
+          <a:solidFill>
+            <a:srgbClr val="161E2E"/>
+          </a:solidFill>
+          <a:ln w="19050">
+            <a:solidFill>
+              <a:srgbClr val="38BDF8"/>
+            </a:solidFill>
+          </a:ln>
+        </p:spPr>
+        <p:style>
+          <a:lnRef idx="1">
+            <a:schemeClr val="accent1"/>
+          </a:lnRef>
+          <a:fillRef idx="3">
+            <a:schemeClr val="accent1"/>
+          </a:fillRef>
+          <a:effectRef idx="2">
+            <a:schemeClr val="accent1"/>
+          </a:effectRef>
+          <a:fontRef idx="minor">
+            <a:schemeClr val="lt1"/>
+          </a:fontRef>
+        </p:style>
+        <p:txBody>
+          <a:bodyPr rtlCol="0" anchor="ctr"/>
+          <a:lstStyle/>
+          <a:p>
+            <a:pPr algn="ctr"/>
+          </a:p>
+        </p:txBody>
+      </p:sp>
+      <p:sp>
+        <p:nvSpPr>
+          <p:cNvPr id="12" name="TextBox 11"/>
+          <p:cNvSpPr txBox="1"/>
+          <p:nvPr/>
+        </p:nvSpPr>
+        <p:spPr>
+          <a:xfrm>
+            <a:off x="8321040" y="4846320"/>
+            <a:ext cx="2926080" cy="1051560"/>
+          </a:xfrm>
+          <a:prstGeom prst="rect">
+            <a:avLst/>
+          </a:prstGeom>
+          <a:noFill/>
+        </p:spPr>
+        <p:txBody>
+          <a:bodyPr wrap="square">
+            <a:spAutoFit/>
+          </a:bodyPr>
+          <a:lstStyle/>
+          <a:p>
+            <a:r>
+              <a:rPr sz="1500" b="1">
+                <a:solidFill>
+                  <a:srgbClr val="38BDF8"/>
                 </a:solidFill>
               </a:rPr>
-              <a:t>Crear nuevas pistas manuales, consultar con filtros dinámicos, editar atributos en modal interactivo y eliminar registros obsoletos.</a:t>
+              <a:t>Búsqueda en Tiempo Real
+</a:t>
             </a:r>
           </a:p>
           <a:p>
             <a:pPr>
               <a:spcBef>
-                <a:spcPts val="800"/>
+                <a:spcPts val="400"/>
               </a:spcBef>
             </a:pPr>
             <a:r>
-              <a:rPr sz="1050" b="1">
-                <a:solidFill>
-                  <a:srgbClr val="F8FAFC"/>
+              <a:rPr sz="1250" b="0">
+                <a:solidFill>
+                  <a:srgbClr val="CBD5E1"/>
                 </a:solidFill>
               </a:rPr>
-              <a:t>• Búsqueda Rápida y Filtros: </a:t>
-            </a:r>
-            <a:r>
-              <a:rPr sz="1000" b="0">
-                <a:solidFill>
-                  <a:srgbClr val="94A3B8"/>
-                </a:solidFill>
-              </a:rPr>
-              <a:t>Filtrado en vivo por texto, género musical y diagnóstico de éxito (Éxito vs Estándar).</a:t>
-            </a:r>
-          </a:p>
-          <a:p>
-            <a:pPr>
-              <a:spcBef>
-                <a:spcPts val="800"/>
-              </a:spcBef>
-            </a:pPr>
-            <a:r>
-              <a:rPr sz="1050" b="1">
-                <a:solidFill>
-                  <a:srgbClr val="F8FAFC"/>
-                </a:solidFill>
-              </a:rPr>
-              <a:t>• Semillado Demostrativo: </a:t>
-            </a:r>
-            <a:r>
-              <a:rPr sz="1000" b="0">
-                <a:solidFill>
-                  <a:srgbClr val="94A3B8"/>
-                </a:solidFill>
-              </a:rPr>
-              <a:t>Carga inicial automática de canciones semilla para evaluación inmediata de la comisión.</a:t>
+              <a:t>Filtrado instantáneo sin recargar la página web.</a:t>
             </a:r>
           </a:p>
         </p:txBody>
@@ -5156,7 +5696,7 @@
             <a:avLst/>
           </a:prstGeom>
           <a:solidFill>
-            <a:srgbClr val="0B0F19"/>
+            <a:srgbClr val="0A0E17"/>
           </a:solidFill>
           <a:ln>
             <a:noFill/>
@@ -5207,12 +5747,12 @@
           <a:lstStyle/>
           <a:p>
             <a:r>
-              <a:rPr sz="1000" b="1">
-                <a:solidFill>
-                  <a:srgbClr val="1DB954"/>
+              <a:rPr sz="1100" b="1">
+                <a:solidFill>
+                  <a:srgbClr val="10B981"/>
                 </a:solidFill>
               </a:rPr>
-              <a:t>ESTABILIDAD Y DESPLIEGUE</a:t>
+              <a:t>CONFIABILIDAD Y ESTABILIDAD</a:t>
             </a:r>
           </a:p>
         </p:txBody>
@@ -5226,7 +5766,7 @@
         <p:spPr>
           <a:xfrm>
             <a:off x="731520" y="640080"/>
-            <a:ext cx="10698480" cy="640080"/>
+            <a:ext cx="10698480" cy="731520"/>
           </a:xfrm>
           <a:prstGeom prst="rect">
             <a:avLst/>
@@ -5240,12 +5780,12 @@
           <a:lstStyle/>
           <a:p>
             <a:r>
-              <a:rPr sz="2200" b="1">
-                <a:solidFill>
-                  <a:srgbClr val="F8FAFC"/>
+              <a:rPr sz="2500" b="1">
+                <a:solidFill>
+                  <a:srgbClr val="FFFFFF"/>
                 </a:solidFill>
               </a:rPr>
-              <a:t>Calidad del Software, Pruebas Unitarias y Despliegue</a:t>
+              <a:t>Calidad de Software y Despliegue en la Nube</a:t>
             </a:r>
           </a:p>
         </p:txBody>
@@ -5259,17 +5799,17 @@
         <p:spPr>
           <a:xfrm>
             <a:off x="731520" y="1463040"/>
-            <a:ext cx="3383280" cy="4754880"/>
+            <a:ext cx="3383280" cy="4846320"/>
           </a:xfrm>
           <a:prstGeom prst="roundRect">
             <a:avLst/>
           </a:prstGeom>
           <a:solidFill>
-            <a:srgbClr val="181F2E"/>
+            <a:srgbClr val="161E2E"/>
           </a:solidFill>
-          <a:ln w="12700">
+          <a:ln w="19050">
             <a:solidFill>
-              <a:srgbClr val="1DB954"/>
+              <a:srgbClr val="10B981"/>
             </a:solidFill>
           </a:ln>
         </p:spPr>
@@ -5303,8 +5843,8 @@
         </p:nvSpPr>
         <p:spPr>
           <a:xfrm>
-            <a:off x="914400" y="1645920"/>
-            <a:ext cx="3017520" cy="4389120"/>
+            <a:off x="960120" y="1691640"/>
+            <a:ext cx="2926080" cy="4389120"/>
           </a:xfrm>
           <a:prstGeom prst="rect">
             <a:avLst/>
@@ -5318,23 +5858,12 @@
           <a:lstStyle/>
           <a:p>
             <a:r>
-              <a:rPr sz="1300" b="1">
-                <a:solidFill>
-                  <a:srgbClr val="1DB954"/>
+              <a:rPr sz="1700" b="1">
+                <a:solidFill>
+                  <a:srgbClr val="10B981"/>
                 </a:solidFill>
               </a:rPr>
-              <a:t>🧪 Pruebas Unitarias (Pytest)
-</a:t>
-            </a:r>
-          </a:p>
-          <a:p>
-            <a:r>
-              <a:rPr sz="1100" b="1">
-                <a:solidFill>
-                  <a:srgbClr val="F8FAFC"/>
-                </a:solidFill>
-              </a:rPr>
-              <a:t>17 Tests Aprobados al 100%
+              <a:t>🧪 17/17 Pruebas Unitarias
 </a:t>
             </a:r>
           </a:p>
@@ -5345,12 +5874,137 @@
               </a:spcBef>
             </a:pPr>
             <a:r>
-              <a:rPr sz="1000" b="0">
-                <a:solidFill>
-                  <a:srgbClr val="94A3B8"/>
+              <a:rPr sz="1300" b="1">
+                <a:solidFill>
+                  <a:srgbClr val="FFFFFF"/>
                 </a:solidFill>
               </a:rPr>
-              <a:t>• test_api.py: Endpoints HTTP, esquemas Pydantic y códigos de respuesta.</a:t>
+              <a:t>100% de Tests Aprobados
+</a:t>
+            </a:r>
+          </a:p>
+          <a:p>
+            <a:pPr>
+              <a:spcBef>
+                <a:spcPts val="800"/>
+              </a:spcBef>
+            </a:pPr>
+            <a:r>
+              <a:rPr sz="1250" b="0">
+                <a:solidFill>
+                  <a:srgbClr val="CBD5E1"/>
+                </a:solidFill>
+              </a:rPr>
+              <a:t>✔ Validación de endpoints en test_api.py</a:t>
+            </a:r>
+          </a:p>
+          <a:p>
+            <a:pPr>
+              <a:spcBef>
+                <a:spcPts val="800"/>
+              </a:spcBef>
+            </a:pPr>
+            <a:r>
+              <a:rPr sz="1250" b="0">
+                <a:solidFill>
+                  <a:srgbClr val="CBD5E1"/>
+                </a:solidFill>
+              </a:rPr>
+              <a:t>✔ Ciclo CRUD completo en test_database.py</a:t>
+            </a:r>
+          </a:p>
+          <a:p>
+            <a:pPr>
+              <a:spcBef>
+                <a:spcPts val="800"/>
+              </a:spcBef>
+            </a:pPr>
+            <a:r>
+              <a:rPr sz="1250" b="0">
+                <a:solidFill>
+                  <a:srgbClr val="CBD5E1"/>
+                </a:solidFill>
+              </a:rPr>
+              <a:t>✔ Inferencia exacta en test_modelos.py</a:t>
+            </a:r>
+          </a:p>
+        </p:txBody>
+      </p:sp>
+      <p:sp>
+        <p:nvSpPr>
+          <p:cNvPr id="7" name="Rounded Rectangle 6"/>
+          <p:cNvSpPr/>
+          <p:nvPr/>
+        </p:nvSpPr>
+        <p:spPr>
+          <a:xfrm>
+            <a:off x="4389120" y="1463040"/>
+            <a:ext cx="3383280" cy="4846320"/>
+          </a:xfrm>
+          <a:prstGeom prst="roundRect">
+            <a:avLst/>
+          </a:prstGeom>
+          <a:solidFill>
+            <a:srgbClr val="161E2E"/>
+          </a:solidFill>
+          <a:ln w="19050">
+            <a:solidFill>
+              <a:srgbClr val="38BDF8"/>
+            </a:solidFill>
+          </a:ln>
+        </p:spPr>
+        <p:style>
+          <a:lnRef idx="1">
+            <a:schemeClr val="accent1"/>
+          </a:lnRef>
+          <a:fillRef idx="3">
+            <a:schemeClr val="accent1"/>
+          </a:fillRef>
+          <a:effectRef idx="2">
+            <a:schemeClr val="accent1"/>
+          </a:effectRef>
+          <a:fontRef idx="minor">
+            <a:schemeClr val="lt1"/>
+          </a:fontRef>
+        </p:style>
+        <p:txBody>
+          <a:bodyPr rtlCol="0" anchor="ctr"/>
+          <a:lstStyle/>
+          <a:p>
+            <a:pPr algn="ctr"/>
+          </a:p>
+        </p:txBody>
+      </p:sp>
+      <p:sp>
+        <p:nvSpPr>
+          <p:cNvPr id="8" name="TextBox 7"/>
+          <p:cNvSpPr txBox="1"/>
+          <p:nvPr/>
+        </p:nvSpPr>
+        <p:spPr>
+          <a:xfrm>
+            <a:off x="4617720" y="1691640"/>
+            <a:ext cx="2926080" cy="4389120"/>
+          </a:xfrm>
+          <a:prstGeom prst="rect">
+            <a:avLst/>
+          </a:prstGeom>
+          <a:noFill/>
+        </p:spPr>
+        <p:txBody>
+          <a:bodyPr wrap="square">
+            <a:spAutoFit/>
+          </a:bodyPr>
+          <a:lstStyle/>
+          <a:p>
+            <a:r>
+              <a:rPr sz="1700" b="1">
+                <a:solidFill>
+                  <a:srgbClr val="38BDF8"/>
+                </a:solidFill>
+              </a:rPr>
+              <a:t>🛡️ Tolerancia a Fallos
+</a:t>
             </a:r>
           </a:p>
           <a:p>
@@ -5360,12 +6014,137 @@
               </a:spcBef>
             </a:pPr>
             <a:r>
-              <a:rPr sz="1000" b="0">
-                <a:solidFill>
-                  <a:srgbClr val="94A3B8"/>
+              <a:rPr sz="1300" b="1">
+                <a:solidFill>
+                  <a:srgbClr val="FFFFFF"/>
                 </a:solidFill>
               </a:rPr>
-              <a:t>• test_database.py: Ciclo CRUD completo en SQLite aislado.</a:t>
+              <a:t>Mensajes Amigables
+</a:t>
+            </a:r>
+          </a:p>
+          <a:p>
+            <a:pPr>
+              <a:spcBef>
+                <a:spcPts val="800"/>
+              </a:spcBef>
+            </a:pPr>
+            <a:r>
+              <a:rPr sz="1250" b="0">
+                <a:solidFill>
+                  <a:srgbClr val="CBD5E1"/>
+                </a:solidFill>
+              </a:rPr>
+              <a:t>✔ Control de esquemas con Pydantic.</a:t>
+            </a:r>
+          </a:p>
+          <a:p>
+            <a:pPr>
+              <a:spcBef>
+                <a:spcPts val="800"/>
+              </a:spcBef>
+            </a:pPr>
+            <a:r>
+              <a:rPr sz="1250" b="0">
+                <a:solidFill>
+                  <a:srgbClr val="CBD5E1"/>
+                </a:solidFill>
+              </a:rPr>
+              <a:t>✔ Cero pantallas de error o tracebacks.</a:t>
+            </a:r>
+          </a:p>
+          <a:p>
+            <a:pPr>
+              <a:spcBef>
+                <a:spcPts val="800"/>
+              </a:spcBef>
+            </a:pPr>
+            <a:r>
+              <a:rPr sz="1250" b="0">
+                <a:solidFill>
+                  <a:srgbClr val="CBD5E1"/>
+                </a:solidFill>
+              </a:rPr>
+              <a:t>✔ Validación de rangos numéricos.</a:t>
+            </a:r>
+          </a:p>
+        </p:txBody>
+      </p:sp>
+      <p:sp>
+        <p:nvSpPr>
+          <p:cNvPr id="9" name="Rounded Rectangle 8"/>
+          <p:cNvSpPr/>
+          <p:nvPr/>
+        </p:nvSpPr>
+        <p:spPr>
+          <a:xfrm>
+            <a:off x="8046720" y="1463040"/>
+            <a:ext cx="3383280" cy="4846320"/>
+          </a:xfrm>
+          <a:prstGeom prst="roundRect">
+            <a:avLst/>
+          </a:prstGeom>
+          <a:solidFill>
+            <a:srgbClr val="161E2E"/>
+          </a:solidFill>
+          <a:ln w="19050">
+            <a:solidFill>
+              <a:srgbClr val="A855F7"/>
+            </a:solidFill>
+          </a:ln>
+        </p:spPr>
+        <p:style>
+          <a:lnRef idx="1">
+            <a:schemeClr val="accent1"/>
+          </a:lnRef>
+          <a:fillRef idx="3">
+            <a:schemeClr val="accent1"/>
+          </a:fillRef>
+          <a:effectRef idx="2">
+            <a:schemeClr val="accent1"/>
+          </a:effectRef>
+          <a:fontRef idx="minor">
+            <a:schemeClr val="lt1"/>
+          </a:fontRef>
+        </p:style>
+        <p:txBody>
+          <a:bodyPr rtlCol="0" anchor="ctr"/>
+          <a:lstStyle/>
+          <a:p>
+            <a:pPr algn="ctr"/>
+          </a:p>
+        </p:txBody>
+      </p:sp>
+      <p:sp>
+        <p:nvSpPr>
+          <p:cNvPr id="10" name="TextBox 9"/>
+          <p:cNvSpPr txBox="1"/>
+          <p:nvPr/>
+        </p:nvSpPr>
+        <p:spPr>
+          <a:xfrm>
+            <a:off x="8275320" y="1691640"/>
+            <a:ext cx="2926080" cy="4389120"/>
+          </a:xfrm>
+          <a:prstGeom prst="rect">
+            <a:avLst/>
+          </a:prstGeom>
+          <a:noFill/>
+        </p:spPr>
+        <p:txBody>
+          <a:bodyPr wrap="square">
+            <a:spAutoFit/>
+          </a:bodyPr>
+          <a:lstStyle/>
+          <a:p>
+            <a:r>
+              <a:rPr sz="1700" b="1">
+                <a:solidFill>
+                  <a:srgbClr val="A855F7"/>
+                </a:solidFill>
+              </a:rPr>
+              <a:t>☁️ Despliegue en Render
+</a:t>
             </a:r>
           </a:p>
           <a:p>
@@ -5375,263 +6154,9 @@
               </a:spcBef>
             </a:pPr>
             <a:r>
-              <a:rPr sz="1000" b="0">
-                <a:solidFill>
-                  <a:srgbClr val="94A3B8"/>
-                </a:solidFill>
-              </a:rPr>
-              <a:t>• test_modelos.py: Carga de joblib, transformador Scaler e inferencia matemática.</a:t>
-            </a:r>
-          </a:p>
-          <a:p>
-            <a:pPr>
-              <a:spcBef>
-                <a:spcPts val="400"/>
-              </a:spcBef>
-            </a:pPr>
-            <a:r>
-              <a:rPr sz="1000" b="0">
-                <a:solidFill>
-                  <a:srgbClr val="94A3B8"/>
-                </a:solidFill>
-              </a:rPr>
-              <a:t>• Tiempo de ejecución: &lt; 3 segundos.</a:t>
-            </a:r>
-          </a:p>
-        </p:txBody>
-      </p:sp>
-      <p:sp>
-        <p:nvSpPr>
-          <p:cNvPr id="7" name="Rounded Rectangle 6"/>
-          <p:cNvSpPr/>
-          <p:nvPr/>
-        </p:nvSpPr>
-        <p:spPr>
-          <a:xfrm>
-            <a:off x="4389120" y="1463040"/>
-            <a:ext cx="3383280" cy="4754880"/>
-          </a:xfrm>
-          <a:prstGeom prst="roundRect">
-            <a:avLst/>
-          </a:prstGeom>
-          <a:solidFill>
-            <a:srgbClr val="181F2E"/>
-          </a:solidFill>
-          <a:ln w="12700">
-            <a:solidFill>
-              <a:srgbClr val="38BDF8"/>
-            </a:solidFill>
-          </a:ln>
-        </p:spPr>
-        <p:style>
-          <a:lnRef idx="1">
-            <a:schemeClr val="accent1"/>
-          </a:lnRef>
-          <a:fillRef idx="3">
-            <a:schemeClr val="accent1"/>
-          </a:fillRef>
-          <a:effectRef idx="2">
-            <a:schemeClr val="accent1"/>
-          </a:effectRef>
-          <a:fontRef idx="minor">
-            <a:schemeClr val="lt1"/>
-          </a:fontRef>
-        </p:style>
-        <p:txBody>
-          <a:bodyPr rtlCol="0" anchor="ctr"/>
-          <a:lstStyle/>
-          <a:p>
-            <a:pPr algn="ctr"/>
-          </a:p>
-        </p:txBody>
-      </p:sp>
-      <p:sp>
-        <p:nvSpPr>
-          <p:cNvPr id="8" name="TextBox 7"/>
-          <p:cNvSpPr txBox="1"/>
-          <p:nvPr/>
-        </p:nvSpPr>
-        <p:spPr>
-          <a:xfrm>
-            <a:off x="4572000" y="1645920"/>
-            <a:ext cx="3017520" cy="4389120"/>
-          </a:xfrm>
-          <a:prstGeom prst="rect">
-            <a:avLst/>
-          </a:prstGeom>
-          <a:noFill/>
-        </p:spPr>
-        <p:txBody>
-          <a:bodyPr wrap="square">
-            <a:spAutoFit/>
-          </a:bodyPr>
-          <a:lstStyle/>
-          <a:p>
-            <a:r>
               <a:rPr sz="1300" b="1">
                 <a:solidFill>
-                  <a:srgbClr val="38BDF8"/>
-                </a:solidFill>
-              </a:rPr>
-              <a:t>🛡️ Tolerancia a Errores
-</a:t>
-            </a:r>
-          </a:p>
-          <a:p>
-            <a:r>
-              <a:rPr sz="1100" b="1">
-                <a:solidFill>
-                  <a:srgbClr val="F8FAFC"/>
-                </a:solidFill>
-              </a:rPr>
-              <a:t>Manejo Amigable en Español
-</a:t>
-            </a:r>
-          </a:p>
-          <a:p>
-            <a:pPr>
-              <a:spcBef>
-                <a:spcPts val="400"/>
-              </a:spcBef>
-            </a:pPr>
-            <a:r>
-              <a:rPr sz="1000" b="0">
-                <a:solidFill>
-                  <a:srgbClr val="94A3B8"/>
-                </a:solidFill>
-              </a:rPr>
-              <a:t>• Captura de excepciones en esquemas Pydantic.</a:t>
-            </a:r>
-          </a:p>
-          <a:p>
-            <a:pPr>
-              <a:spcBef>
-                <a:spcPts val="400"/>
-              </a:spcBef>
-            </a:pPr>
-            <a:r>
-              <a:rPr sz="1000" b="0">
-                <a:solidFill>
-                  <a:srgbClr val="94A3B8"/>
-                </a:solidFill>
-              </a:rPr>
-              <a:t>• Cero pantallas de error o tracebacks de Python para el usuario final.</a:t>
-            </a:r>
-          </a:p>
-          <a:p>
-            <a:pPr>
-              <a:spcBef>
-                <a:spcPts val="400"/>
-              </a:spcBef>
-            </a:pPr>
-            <a:r>
-              <a:rPr sz="1000" b="0">
-                <a:solidFill>
-                  <a:srgbClr val="94A3B8"/>
-                </a:solidFill>
-              </a:rPr>
-              <a:t>• Alertas visuales en interfaz ante valores fuera de rango.</a:t>
-            </a:r>
-          </a:p>
-          <a:p>
-            <a:pPr>
-              <a:spcBef>
-                <a:spcPts val="400"/>
-              </a:spcBef>
-            </a:pPr>
-            <a:r>
-              <a:rPr sz="1000" b="0">
-                <a:solidFill>
-                  <a:srgbClr val="94A3B8"/>
-                </a:solidFill>
-              </a:rPr>
-              <a:t>• Auto-recuperación de conexión a base de datos.</a:t>
-            </a:r>
-          </a:p>
-        </p:txBody>
-      </p:sp>
-      <p:sp>
-        <p:nvSpPr>
-          <p:cNvPr id="9" name="Rounded Rectangle 8"/>
-          <p:cNvSpPr/>
-          <p:nvPr/>
-        </p:nvSpPr>
-        <p:spPr>
-          <a:xfrm>
-            <a:off x="8046720" y="1463040"/>
-            <a:ext cx="3383280" cy="4754880"/>
-          </a:xfrm>
-          <a:prstGeom prst="roundRect">
-            <a:avLst/>
-          </a:prstGeom>
-          <a:solidFill>
-            <a:srgbClr val="181F2E"/>
-          </a:solidFill>
-          <a:ln w="12700">
-            <a:solidFill>
-              <a:srgbClr val="A855F7"/>
-            </a:solidFill>
-          </a:ln>
-        </p:spPr>
-        <p:style>
-          <a:lnRef idx="1">
-            <a:schemeClr val="accent1"/>
-          </a:lnRef>
-          <a:fillRef idx="3">
-            <a:schemeClr val="accent1"/>
-          </a:fillRef>
-          <a:effectRef idx="2">
-            <a:schemeClr val="accent1"/>
-          </a:effectRef>
-          <a:fontRef idx="minor">
-            <a:schemeClr val="lt1"/>
-          </a:fontRef>
-        </p:style>
-        <p:txBody>
-          <a:bodyPr rtlCol="0" anchor="ctr"/>
-          <a:lstStyle/>
-          <a:p>
-            <a:pPr algn="ctr"/>
-          </a:p>
-        </p:txBody>
-      </p:sp>
-      <p:sp>
-        <p:nvSpPr>
-          <p:cNvPr id="10" name="TextBox 9"/>
-          <p:cNvSpPr txBox="1"/>
-          <p:nvPr/>
-        </p:nvSpPr>
-        <p:spPr>
-          <a:xfrm>
-            <a:off x="8229600" y="1645920"/>
-            <a:ext cx="3017520" cy="4389120"/>
-          </a:xfrm>
-          <a:prstGeom prst="rect">
-            <a:avLst/>
-          </a:prstGeom>
-          <a:noFill/>
-        </p:spPr>
-        <p:txBody>
-          <a:bodyPr wrap="square">
-            <a:spAutoFit/>
-          </a:bodyPr>
-          <a:lstStyle/>
-          <a:p>
-            <a:r>
-              <a:rPr sz="1300" b="1">
-                <a:solidFill>
-                  <a:srgbClr val="A855F7"/>
-                </a:solidFill>
-              </a:rPr>
-              <a:t>☁️ Despliegue Cloud (Render)
-</a:t>
-            </a:r>
-          </a:p>
-          <a:p>
-            <a:r>
-              <a:rPr sz="1100" b="1">
-                <a:solidFill>
-                  <a:srgbClr val="F8FAFC"/>
+                  <a:srgbClr val="FFFFFF"/>
                 </a:solidFill>
               </a:rPr>
               <a:t>Acceso Público 24/7
@@ -5641,61 +6166,46 @@
           <a:p>
             <a:pPr>
               <a:spcBef>
-                <a:spcPts val="400"/>
+                <a:spcPts val="800"/>
               </a:spcBef>
             </a:pPr>
             <a:r>
-              <a:rPr sz="1000" b="0">
-                <a:solidFill>
-                  <a:srgbClr val="94A3B8"/>
+              <a:rPr sz="1250" b="0">
+                <a:solidFill>
+                  <a:srgbClr val="CBD5E1"/>
                 </a:solidFill>
               </a:rPr>
-              <a:t>• Servidor ASGI Uvicorn contenerizable.</a:t>
+              <a:t>✔ Servidor ASGI Uvicorn contenerizable.</a:t>
             </a:r>
           </a:p>
           <a:p>
             <a:pPr>
               <a:spcBef>
-                <a:spcPts val="400"/>
+                <a:spcPts val="800"/>
               </a:spcBef>
             </a:pPr>
             <a:r>
-              <a:rPr sz="1000" b="0">
-                <a:solidFill>
-                  <a:srgbClr val="94A3B8"/>
+              <a:rPr sz="1250" b="0">
+                <a:solidFill>
+                  <a:srgbClr val="CBD5E1"/>
                 </a:solidFill>
               </a:rPr>
-              <a:t>• Archivo Procfile configurado en la raíz.</a:t>
+              <a:t>✔ Integración continua desde GitHub.</a:t>
             </a:r>
           </a:p>
           <a:p>
             <a:pPr>
               <a:spcBef>
-                <a:spcPts val="400"/>
+                <a:spcPts val="800"/>
               </a:spcBef>
             </a:pPr>
             <a:r>
-              <a:rPr sz="1000" b="0">
-                <a:solidFill>
-                  <a:srgbClr val="94A3B8"/>
+              <a:rPr sz="1250" b="0">
+                <a:solidFill>
+                  <a:srgbClr val="CBD5E1"/>
                 </a:solidFill>
               </a:rPr>
-              <a:t>• Repositorio sincronizado con GitHub CI/CD.</a:t>
-            </a:r>
-          </a:p>
-          <a:p>
-            <a:pPr>
-              <a:spcBef>
-                <a:spcPts val="400"/>
-              </a:spcBef>
-            </a:pPr>
-            <a:r>
-              <a:rPr sz="1000" b="0">
-                <a:solidFill>
-                  <a:srgbClr val="94A3B8"/>
-                </a:solidFill>
-              </a:rPr>
-              <a:t>• Video de respaldo de 2 min ante contingencias de red.</a:t>
+              <a:t>✔ Video de respaldo de 2 minutos.</a:t>
             </a:r>
           </a:p>
         </p:txBody>

</xml_diff>